<commit_message>
feat(p06): penguatan pedagogi perbandingan cubit vs bloc dan konsep stream
</commit_message>
<xml_diff>
--- a/03_slide_presentasi/PERTEMUAN_06_State_Management_Cubit_dan_BLoC.pptx
+++ b/03_slide_presentasi/PERTEMUAN_06_State_Management_Cubit_dan_BLoC.pptx
@@ -14607,7 +14607,7 @@
               </a:defRPr>
             </a:pPr>
             <a:r>
-              <a:t>Mental Model Cubit: Pabrik Radio &amp; Remot Pemancar Siaran</a:t>
+              <a:t>Mental Model Cubit: Pabrik Radio &amp; Konsep Stream Reaktif</a:t>
             </a:r>
           </a:p>
         </p:txBody>
@@ -14815,7 +14815,7 @@
               </a:defRPr>
             </a:pPr>
             <a:r>
-              <a:t>■  📻 Analogi Pabrik Radio: Cubit bertindak sebagai stasiun radio pemancar. Widget UI adalah radio penerima yang mendengarkan siaran frekuensi.</a:t>
+              <a:t>■  📻 Analogi Pabrik Radio: Cubit bertindak sebagai stasiun pemancar. Widget UI adalah radio penerima yang mendengarkan siaran frekuensi.</a:t>
             </a:r>
           </a:p>
           <a:p>
@@ -14831,7 +14831,7 @@
               </a:defRPr>
             </a:pPr>
             <a:r>
-              <a:t>■  🧠 Otak vs Otot: Cubit adalah otak yang memproses angka dan data; Widget adalah otot yang sekadar menggambar pixel ke layar.</a:t>
+              <a:t>■  🌊 Konsep Stream: Di balik layar, Cubit adalah pipa aliran data (Stream). Setiap emit() mengalirkan data baru ke widget secara instan.</a:t>
             </a:r>
           </a:p>
           <a:p>
@@ -14847,7 +14847,7 @@
               </a:defRPr>
             </a:pPr>
             <a:r>
-              <a:t>■  ⚡ Alur Satu Arah (Unidirectional): User klik tombol -&gt; Panggil method Cubit -&gt; Cubit memancarkan State baru -&gt; UI otomatis berubah.</a:t>
+              <a:t>■  ⚖️ Cubit vs BLoC: Cubit memakai fungsi langsung (ringkas untuk 90% aplikasi). BLoC memakai objek Event (untuk debounce pencarian).</a:t>
             </a:r>
           </a:p>
           <a:p>
@@ -14863,7 +14863,7 @@
               </a:defRPr>
             </a:pPr>
             <a:r>
-              <a:t>■  🛡️ Bersih Total: File Cubit murni berisi kode logika Dart tanpa ada satu pun widget Scaffold, Text, atau MaterialApp!</a:t>
+              <a:t>■  🧠 Otak vs Otot: Cubit murni kode logika Dart tanpa widget; UI murni bertugas menggambar pixel ke layar tanpa logika bisnis.</a:t>
             </a:r>
           </a:p>
         </p:txBody>
@@ -14948,7 +14948,7 @@
             </a:r>
             <a:br/>
             <a:r>
-              <a:t>Karena bebas dari dependensi UI, file Cubit dapat diuji secara otomatis via Unit Test dalam 0.1 detik!</a:t>
+              <a:t>Gunakan Cubit untuk 90% fitur aplikasi! Beralihlah ke full BLoC hanya jika Anda butuh debounce pada Live Search Bar.</a:t>
             </a:r>
           </a:p>
         </p:txBody>
@@ -16812,7 +16812,7 @@
             </a:r>
             <a:br/>
             <a:r>
-              <a:t>Dilarang memanggil emit() jika nilai baru persis sama dengan nilai lama (Equatable otomatis memblokirnya)!</a:t>
+              <a:t>Dilarang emit() jika nilai sama, dan selalu cek 'if (!isClosed) emit(...)' pada operasi async agar bebas bug!</a:t>
             </a:r>
           </a:p>
         </p:txBody>

</xml_diff>